<commit_message>
Add: approvements from Tobi
</commit_message>
<xml_diff>
--- a/Images.pptx
+++ b/Images.pptx
@@ -6,6 +6,7 @@
   </p:sldMasterIdLst>
   <p:sldIdLst>
     <p:sldId id="256" r:id="rId2"/>
+    <p:sldId id="257" r:id="rId3"/>
   </p:sldIdLst>
   <p:sldSz cx="12192000" cy="6858000"/>
   <p:notesSz cx="6858000" cy="9144000"/>
@@ -104,7 +105,121 @@
       </a:defRPr>
     </a:lvl9pPr>
   </p:defaultTextStyle>
+  <p:extLst>
+    <p:ext uri="{EFAFB233-063F-42B5-8137-9DF3F51BA10A}">
+      <p15:sldGuideLst xmlns:p15="http://schemas.microsoft.com/office/powerpoint/2012/main"/>
+    </p:ext>
+  </p:extLst>
 </p:presentation>
+</file>
+
+<file path=ppt/revisionInfo.xml><?xml version="1.0" encoding="utf-8"?>
+<p1510:revInfo xmlns:a="http://schemas.openxmlformats.org/drawingml/2006/main" xmlns:r="http://schemas.openxmlformats.org/officeDocument/2006/relationships" xmlns:p1510="http://schemas.microsoft.com/office/powerpoint/2015/10/main">
+  <p1510:revLst>
+    <p1510:client id="{0418EDEE-A7F7-44AA-B89F-6F0A5CFB3B5C}" v="5" dt="2026-05-26T16:11:58.852"/>
+  </p1510:revLst>
+</p1510:revInfo>
+</file>
+
+<file path=ppt/changesInfos/changesInfo1.xml><?xml version="1.0" encoding="utf-8"?>
+<pc:chgInfo xmlns:a="http://schemas.openxmlformats.org/drawingml/2006/main" xmlns:r="http://schemas.openxmlformats.org/officeDocument/2006/relationships" xmlns:ac="http://schemas.microsoft.com/office/drawing/2013/main/command" xmlns:pc="http://schemas.microsoft.com/office/powerpoint/2013/main/command">
+  <pc:docChgLst>
+    <pc:chgData name="Sebastian Weidner" userId="101dffdc101332ca" providerId="LiveId" clId="{ACF21893-0E61-493C-91F1-69A518166014}"/>
+    <pc:docChg chg="undo custSel addSld modSld">
+      <pc:chgData name="Sebastian Weidner" userId="101dffdc101332ca" providerId="LiveId" clId="{ACF21893-0E61-493C-91F1-69A518166014}" dt="2026-05-26T16:11:58.852" v="26" actId="164"/>
+      <pc:docMkLst>
+        <pc:docMk/>
+      </pc:docMkLst>
+      <pc:sldChg chg="addSp delSp modSp new mod">
+        <pc:chgData name="Sebastian Weidner" userId="101dffdc101332ca" providerId="LiveId" clId="{ACF21893-0E61-493C-91F1-69A518166014}" dt="2026-05-26T16:11:58.852" v="26" actId="164"/>
+        <pc:sldMkLst>
+          <pc:docMk/>
+          <pc:sldMk cId="2802566386" sldId="257"/>
+        </pc:sldMkLst>
+        <pc:spChg chg="del">
+          <ac:chgData name="Sebastian Weidner" userId="101dffdc101332ca" providerId="LiveId" clId="{ACF21893-0E61-493C-91F1-69A518166014}" dt="2026-05-26T16:10:31.467" v="4" actId="478"/>
+          <ac:spMkLst>
+            <pc:docMk/>
+            <pc:sldMk cId="2802566386" sldId="257"/>
+            <ac:spMk id="2" creationId="{0364417D-AEB6-18CE-CB70-2BB25E501225}"/>
+          </ac:spMkLst>
+        </pc:spChg>
+        <pc:spChg chg="del">
+          <ac:chgData name="Sebastian Weidner" userId="101dffdc101332ca" providerId="LiveId" clId="{ACF21893-0E61-493C-91F1-69A518166014}" dt="2026-05-26T16:10:30.715" v="3" actId="478"/>
+          <ac:spMkLst>
+            <pc:docMk/>
+            <pc:sldMk cId="2802566386" sldId="257"/>
+            <ac:spMk id="3" creationId="{B4779A75-70C4-D4A3-695A-AEE19D5E4D7B}"/>
+          </ac:spMkLst>
+        </pc:spChg>
+        <pc:spChg chg="add del mod">
+          <ac:chgData name="Sebastian Weidner" userId="101dffdc101332ca" providerId="LiveId" clId="{ACF21893-0E61-493C-91F1-69A518166014}" dt="2026-05-26T16:11:04.439" v="6" actId="478"/>
+          <ac:spMkLst>
+            <pc:docMk/>
+            <pc:sldMk cId="2802566386" sldId="257"/>
+            <ac:spMk id="6" creationId="{E094E92D-94E0-64FE-F338-3340917A4E20}"/>
+          </ac:spMkLst>
+        </pc:spChg>
+        <pc:spChg chg="add mod">
+          <ac:chgData name="Sebastian Weidner" userId="101dffdc101332ca" providerId="LiveId" clId="{ACF21893-0E61-493C-91F1-69A518166014}" dt="2026-05-26T16:10:25.090" v="2"/>
+          <ac:spMkLst>
+            <pc:docMk/>
+            <pc:sldMk cId="2802566386" sldId="257"/>
+            <ac:spMk id="7" creationId="{34DB6C5C-A157-801E-42A6-DA9132696BF2}"/>
+          </ac:spMkLst>
+        </pc:spChg>
+        <pc:spChg chg="add mod">
+          <ac:chgData name="Sebastian Weidner" userId="101dffdc101332ca" providerId="LiveId" clId="{ACF21893-0E61-493C-91F1-69A518166014}" dt="2026-05-26T16:11:58.852" v="26" actId="164"/>
+          <ac:spMkLst>
+            <pc:docMk/>
+            <pc:sldMk cId="2802566386" sldId="257"/>
+            <ac:spMk id="10" creationId="{4738F532-37AA-B31F-C642-7E7D39F7C6C8}"/>
+          </ac:spMkLst>
+        </pc:spChg>
+        <pc:grpChg chg="add mod">
+          <ac:chgData name="Sebastian Weidner" userId="101dffdc101332ca" providerId="LiveId" clId="{ACF21893-0E61-493C-91F1-69A518166014}" dt="2026-05-26T16:11:58.852" v="26" actId="164"/>
+          <ac:grpSpMkLst>
+            <pc:docMk/>
+            <pc:sldMk cId="2802566386" sldId="257"/>
+            <ac:grpSpMk id="11" creationId="{F0ADB6FD-F483-DD39-484A-A1D2EFEB0FDA}"/>
+          </ac:grpSpMkLst>
+        </pc:grpChg>
+        <pc:picChg chg="add del mod">
+          <ac:chgData name="Sebastian Weidner" userId="101dffdc101332ca" providerId="LiveId" clId="{ACF21893-0E61-493C-91F1-69A518166014}" dt="2026-05-26T16:11:04.439" v="6" actId="478"/>
+          <ac:picMkLst>
+            <pc:docMk/>
+            <pc:sldMk cId="2802566386" sldId="257"/>
+            <ac:picMk id="4" creationId="{B3EB2568-504A-724F-B4E6-2501B83CE935}"/>
+          </ac:picMkLst>
+        </pc:picChg>
+        <pc:picChg chg="add del mod">
+          <ac:chgData name="Sebastian Weidner" userId="101dffdc101332ca" providerId="LiveId" clId="{ACF21893-0E61-493C-91F1-69A518166014}" dt="2026-05-26T16:11:04.439" v="6" actId="478"/>
+          <ac:picMkLst>
+            <pc:docMk/>
+            <pc:sldMk cId="2802566386" sldId="257"/>
+            <ac:picMk id="5" creationId="{B098256C-626C-0AA1-E760-285107C47CD0}"/>
+          </ac:picMkLst>
+        </pc:picChg>
+        <pc:picChg chg="add mod">
+          <ac:chgData name="Sebastian Weidner" userId="101dffdc101332ca" providerId="LiveId" clId="{ACF21893-0E61-493C-91F1-69A518166014}" dt="2026-05-26T16:11:58.852" v="26" actId="164"/>
+          <ac:picMkLst>
+            <pc:docMk/>
+            <pc:sldMk cId="2802566386" sldId="257"/>
+            <ac:picMk id="8" creationId="{4AF4DBB6-1EBA-A356-1587-8C421228B618}"/>
+          </ac:picMkLst>
+        </pc:picChg>
+        <pc:picChg chg="add mod">
+          <ac:chgData name="Sebastian Weidner" userId="101dffdc101332ca" providerId="LiveId" clId="{ACF21893-0E61-493C-91F1-69A518166014}" dt="2026-05-26T16:11:58.852" v="26" actId="164"/>
+          <ac:picMkLst>
+            <pc:docMk/>
+            <pc:sldMk cId="2802566386" sldId="257"/>
+            <ac:picMk id="9" creationId="{59BD2A3B-A91F-CC3C-DB58-80F6993E440E}"/>
+          </ac:picMkLst>
+        </pc:picChg>
+      </pc:sldChg>
+    </pc:docChg>
+  </pc:docChgLst>
+</pc:chgInfo>
 </file>
 
 <file path=ppt/slideLayouts/slideLayout1.xml><?xml version="1.0" encoding="utf-8"?>
@@ -256,7 +371,7 @@
           <a:p>
             <a:fld id="{B1EBFEE7-7531-4E77-B4BF-D2DE7961ABD0}" type="datetimeFigureOut">
               <a:rPr lang="en-US" smtClean="0"/>
-              <a:t>4/27/2026</a:t>
+              <a:t>5/26/2026</a:t>
             </a:fld>
             <a:endParaRPr lang="en-US"/>
           </a:p>
@@ -456,7 +571,7 @@
           <a:p>
             <a:fld id="{B1EBFEE7-7531-4E77-B4BF-D2DE7961ABD0}" type="datetimeFigureOut">
               <a:rPr lang="en-US" smtClean="0"/>
-              <a:t>4/27/2026</a:t>
+              <a:t>5/26/2026</a:t>
             </a:fld>
             <a:endParaRPr lang="en-US"/>
           </a:p>
@@ -666,7 +781,7 @@
           <a:p>
             <a:fld id="{B1EBFEE7-7531-4E77-B4BF-D2DE7961ABD0}" type="datetimeFigureOut">
               <a:rPr lang="en-US" smtClean="0"/>
-              <a:t>4/27/2026</a:t>
+              <a:t>5/26/2026</a:t>
             </a:fld>
             <a:endParaRPr lang="en-US"/>
           </a:p>
@@ -866,7 +981,7 @@
           <a:p>
             <a:fld id="{B1EBFEE7-7531-4E77-B4BF-D2DE7961ABD0}" type="datetimeFigureOut">
               <a:rPr lang="en-US" smtClean="0"/>
-              <a:t>4/27/2026</a:t>
+              <a:t>5/26/2026</a:t>
             </a:fld>
             <a:endParaRPr lang="en-US"/>
           </a:p>
@@ -1142,7 +1257,7 @@
           <a:p>
             <a:fld id="{B1EBFEE7-7531-4E77-B4BF-D2DE7961ABD0}" type="datetimeFigureOut">
               <a:rPr lang="en-US" smtClean="0"/>
-              <a:t>4/27/2026</a:t>
+              <a:t>5/26/2026</a:t>
             </a:fld>
             <a:endParaRPr lang="en-US"/>
           </a:p>
@@ -1410,7 +1525,7 @@
           <a:p>
             <a:fld id="{B1EBFEE7-7531-4E77-B4BF-D2DE7961ABD0}" type="datetimeFigureOut">
               <a:rPr lang="en-US" smtClean="0"/>
-              <a:t>4/27/2026</a:t>
+              <a:t>5/26/2026</a:t>
             </a:fld>
             <a:endParaRPr lang="en-US"/>
           </a:p>
@@ -1825,7 +1940,7 @@
           <a:p>
             <a:fld id="{B1EBFEE7-7531-4E77-B4BF-D2DE7961ABD0}" type="datetimeFigureOut">
               <a:rPr lang="en-US" smtClean="0"/>
-              <a:t>4/27/2026</a:t>
+              <a:t>5/26/2026</a:t>
             </a:fld>
             <a:endParaRPr lang="en-US"/>
           </a:p>
@@ -1967,7 +2082,7 @@
           <a:p>
             <a:fld id="{B1EBFEE7-7531-4E77-B4BF-D2DE7961ABD0}" type="datetimeFigureOut">
               <a:rPr lang="en-US" smtClean="0"/>
-              <a:t>4/27/2026</a:t>
+              <a:t>5/26/2026</a:t>
             </a:fld>
             <a:endParaRPr lang="en-US"/>
           </a:p>
@@ -2080,7 +2195,7 @@
           <a:p>
             <a:fld id="{B1EBFEE7-7531-4E77-B4BF-D2DE7961ABD0}" type="datetimeFigureOut">
               <a:rPr lang="en-US" smtClean="0"/>
-              <a:t>4/27/2026</a:t>
+              <a:t>5/26/2026</a:t>
             </a:fld>
             <a:endParaRPr lang="en-US"/>
           </a:p>
@@ -2393,7 +2508,7 @@
           <a:p>
             <a:fld id="{B1EBFEE7-7531-4E77-B4BF-D2DE7961ABD0}" type="datetimeFigureOut">
               <a:rPr lang="en-US" smtClean="0"/>
-              <a:t>4/27/2026</a:t>
+              <a:t>5/26/2026</a:t>
             </a:fld>
             <a:endParaRPr lang="en-US"/>
           </a:p>
@@ -2682,7 +2797,7 @@
           <a:p>
             <a:fld id="{B1EBFEE7-7531-4E77-B4BF-D2DE7961ABD0}" type="datetimeFigureOut">
               <a:rPr lang="en-US" smtClean="0"/>
-              <a:t>4/27/2026</a:t>
+              <a:t>5/26/2026</a:t>
             </a:fld>
             <a:endParaRPr lang="en-US"/>
           </a:p>
@@ -2925,7 +3040,7 @@
           <a:p>
             <a:fld id="{B1EBFEE7-7531-4E77-B4BF-D2DE7961ABD0}" type="datetimeFigureOut">
               <a:rPr lang="en-US" smtClean="0"/>
-              <a:t>4/27/2026</a:t>
+              <a:t>5/26/2026</a:t>
             </a:fld>
             <a:endParaRPr lang="en-US"/>
           </a:p>
@@ -3517,6 +3632,186 @@
 </p:sld>
 </file>
 
+<file path=ppt/slides/slide2.xml><?xml version="1.0" encoding="utf-8"?>
+<p:sld xmlns:a="http://schemas.openxmlformats.org/drawingml/2006/main" xmlns:r="http://schemas.openxmlformats.org/officeDocument/2006/relationships" xmlns:p="http://schemas.openxmlformats.org/presentationml/2006/main">
+  <p:cSld>
+    <p:spTree>
+      <p:nvGrpSpPr>
+        <p:cNvPr id="1" name=""/>
+        <p:cNvGrpSpPr/>
+        <p:nvPr/>
+      </p:nvGrpSpPr>
+      <p:grpSpPr>
+        <a:xfrm>
+          <a:off x="0" y="0"/>
+          <a:ext cx="0" cy="0"/>
+          <a:chOff x="0" y="0"/>
+          <a:chExt cx="0" cy="0"/>
+        </a:xfrm>
+      </p:grpSpPr>
+      <p:grpSp>
+        <p:nvGrpSpPr>
+          <p:cNvPr id="11" name="Gruppieren 10">
+            <a:extLst>
+              <a:ext uri="{FF2B5EF4-FFF2-40B4-BE49-F238E27FC236}">
+                <a16:creationId xmlns:a16="http://schemas.microsoft.com/office/drawing/2014/main" id="{F0ADB6FD-F483-DD39-484A-A1D2EFEB0FDA}"/>
+              </a:ext>
+            </a:extLst>
+          </p:cNvPr>
+          <p:cNvGrpSpPr/>
+          <p:nvPr/>
+        </p:nvGrpSpPr>
+        <p:grpSpPr>
+          <a:xfrm>
+            <a:off x="488354" y="1551464"/>
+            <a:ext cx="10810767" cy="4757084"/>
+            <a:chOff x="488354" y="1551464"/>
+            <a:chExt cx="10810767" cy="4757084"/>
+          </a:xfrm>
+        </p:grpSpPr>
+        <p:pic>
+          <p:nvPicPr>
+            <p:cNvPr id="8" name="Grafik 7">
+              <a:extLst>
+                <a:ext uri="{FF2B5EF4-FFF2-40B4-BE49-F238E27FC236}">
+                  <a16:creationId xmlns:a16="http://schemas.microsoft.com/office/drawing/2014/main" id="{4AF4DBB6-1EBA-A356-1587-8C421228B618}"/>
+                </a:ext>
+              </a:extLst>
+            </p:cNvPr>
+            <p:cNvPicPr>
+              <a:picLocks noChangeAspect="1"/>
+            </p:cNvPicPr>
+            <p:nvPr/>
+          </p:nvPicPr>
+          <p:blipFill>
+            <a:blip r:embed="rId2"/>
+            <a:srcRect t="21520"/>
+            <a:stretch>
+              <a:fillRect/>
+            </a:stretch>
+          </p:blipFill>
+          <p:spPr>
+            <a:xfrm>
+              <a:off x="6622739" y="1551464"/>
+              <a:ext cx="4676382" cy="4757084"/>
+            </a:xfrm>
+            <a:prstGeom prst="rect">
+              <a:avLst/>
+            </a:prstGeom>
+          </p:spPr>
+        </p:pic>
+        <p:pic>
+          <p:nvPicPr>
+            <p:cNvPr id="9" name="Grafik 8">
+              <a:extLst>
+                <a:ext uri="{FF2B5EF4-FFF2-40B4-BE49-F238E27FC236}">
+                  <a16:creationId xmlns:a16="http://schemas.microsoft.com/office/drawing/2014/main" id="{59BD2A3B-A91F-CC3C-DB58-80F6993E440E}"/>
+                </a:ext>
+              </a:extLst>
+            </p:cNvPr>
+            <p:cNvPicPr>
+              <a:picLocks noChangeAspect="1"/>
+            </p:cNvPicPr>
+            <p:nvPr/>
+          </p:nvPicPr>
+          <p:blipFill>
+            <a:blip r:embed="rId2"/>
+            <a:srcRect b="79460"/>
+            <a:stretch>
+              <a:fillRect/>
+            </a:stretch>
+          </p:blipFill>
+          <p:spPr>
+            <a:xfrm>
+              <a:off x="488354" y="3281448"/>
+              <a:ext cx="4676382" cy="1245018"/>
+            </a:xfrm>
+            <a:prstGeom prst="rect">
+              <a:avLst/>
+            </a:prstGeom>
+          </p:spPr>
+        </p:pic>
+        <p:sp>
+          <p:nvSpPr>
+            <p:cNvPr id="10" name="Pfeil: nach rechts 9">
+              <a:extLst>
+                <a:ext uri="{FF2B5EF4-FFF2-40B4-BE49-F238E27FC236}">
+                  <a16:creationId xmlns:a16="http://schemas.microsoft.com/office/drawing/2014/main" id="{4738F532-37AA-B31F-C642-7E7D39F7C6C8}"/>
+                </a:ext>
+              </a:extLst>
+            </p:cNvPr>
+            <p:cNvSpPr/>
+            <p:nvPr/>
+          </p:nvSpPr>
+          <p:spPr bwMode="gray">
+            <a:xfrm>
+              <a:off x="5455920" y="3697494"/>
+              <a:ext cx="938198" cy="412926"/>
+            </a:xfrm>
+            <a:prstGeom prst="rightArrow">
+              <a:avLst/>
+            </a:prstGeom>
+            <a:solidFill>
+              <a:srgbClr val="F19400"/>
+            </a:solidFill>
+            <a:ln w="25400" cap="flat" cmpd="sng" algn="ctr">
+              <a:noFill/>
+              <a:prstDash val="solid"/>
+            </a:ln>
+            <a:effectLst/>
+          </p:spPr>
+          <p:txBody>
+            <a:bodyPr lIns="36000" tIns="36000" rIns="36000" bIns="36000" rtlCol="0" anchor="ctr"/>
+            <a:lstStyle/>
+            <a:p>
+              <a:pPr marL="0" marR="0" lvl="0" indent="0" algn="ctr" defTabSz="914400" eaLnBrk="1" fontAlgn="auto" latinLnBrk="0" hangingPunct="1">
+                <a:lnSpc>
+                  <a:spcPct val="90000"/>
+                </a:lnSpc>
+                <a:spcBef>
+                  <a:spcPts val="0"/>
+                </a:spcBef>
+                <a:spcAft>
+                  <a:spcPts val="1000"/>
+                </a:spcAft>
+                <a:buClrTx/>
+                <a:buSzTx/>
+                <a:buFontTx/>
+                <a:buNone/>
+                <a:tabLst/>
+                <a:defRPr/>
+              </a:pPr>
+              <a:endParaRPr kumimoji="0" lang="en-US" sz="1400" b="0" i="0" u="none" strike="noStrike" kern="0" cap="none" spc="0" normalizeH="0" baseline="0" noProof="0" dirty="0">
+                <a:ln>
+                  <a:noFill/>
+                </a:ln>
+                <a:solidFill>
+                  <a:srgbClr val="FFFFFF"/>
+                </a:solidFill>
+                <a:effectLst/>
+                <a:uLnTx/>
+                <a:uFillTx/>
+                <a:latin typeface="Meta OT" panose="020B0504030101020104" pitchFamily="34" charset="0"/>
+                <a:ea typeface="+mn-ea"/>
+                <a:cs typeface="+mn-cs"/>
+              </a:endParaRPr>
+            </a:p>
+          </p:txBody>
+        </p:sp>
+      </p:grpSp>
+    </p:spTree>
+    <p:extLst>
+      <p:ext uri="{BB962C8B-B14F-4D97-AF65-F5344CB8AC3E}">
+        <p14:creationId xmlns:p14="http://schemas.microsoft.com/office/powerpoint/2010/main" val="2802566386"/>
+      </p:ext>
+    </p:extLst>
+  </p:cSld>
+  <p:clrMapOvr>
+    <a:masterClrMapping/>
+  </p:clrMapOvr>
+</p:sld>
+</file>
+
 <file path=ppt/theme/theme1.xml><?xml version="1.0" encoding="utf-8"?>
 <a:theme xmlns:a="http://schemas.openxmlformats.org/drawingml/2006/main" name="Office">
   <a:themeElements>

</xml_diff>